<commit_message>
Fix title wrapping and footer overflow on slides 2, 4, 7, 10, 11, 13
Co-authored-by: ms4674 <ms4674@users.noreply.github.com>
</commit_message>
<xml_diff>
--- a/agentic_ai_market_finance.pptx
+++ b/agentic_ai_market_finance.pptx
@@ -4254,7 +4254,7 @@
                 </a:solidFill>
                 <a:latin typeface="Calibri Light"/>
               </a:rPr>
-              <a:t>Adoption: half the industry is in motion, a quarter is scaling</a:t>
+              <a:t>Adoption: half in motion, a quarter scaling</a:t>
             </a:r>
           </a:p>
         </p:txBody>
@@ -5956,7 +5956,7 @@
         </p:nvSpPr>
         <p:spPr>
           <a:xfrm>
-            <a:off x="566928" y="6108192"/>
+            <a:off x="566928" y="6126480"/>
             <a:ext cx="11057839" cy="365760"/>
           </a:xfrm>
           <a:prstGeom prst="rect">
@@ -5991,7 +5991,7 @@
                 </a:solidFill>
                 <a:latin typeface="Calibri"/>
               </a:rPr>
-              <a:t>the first production wins are back- and middle-office — high volume, clear policy, measurable unit cost — before customer-facing autonomy.</a:t>
+              <a:t>the first production wins are back- and middle-office — high volume, clear policy, measurable unit cost.</a:t>
             </a:r>
           </a:p>
         </p:txBody>
@@ -7733,7 +7733,7 @@
         </p:nvSpPr>
         <p:spPr>
           <a:xfrm>
-            <a:off x="566928" y="6108192"/>
+            <a:off x="566928" y="6126480"/>
             <a:ext cx="11057839" cy="365760"/>
           </a:xfrm>
           <a:prstGeom prst="rect">
@@ -7753,7 +7753,7 @@
               </a:lnSpc>
             </a:pPr>
             <a:r>
-              <a:rPr sz="1250" b="1">
+              <a:rPr sz="1200" b="1">
                 <a:solidFill>
                   <a:srgbClr val="0B1E3D"/>
                 </a:solidFill>
@@ -7762,13 +7762,13 @@
               <a:t>Signal:  </a:t>
             </a:r>
             <a:r>
-              <a:rPr sz="1250" b="0">
+              <a:rPr sz="1200" b="0">
                 <a:solidFill>
                   <a:srgbClr val="5A6B85"/>
                 </a:solidFill>
                 <a:latin typeface="Calibri"/>
               </a:rPr>
-              <a:t>the largest, most-regulated institutions are past experimentation — they are naming systems, publishing accuracy figures, and building payment rails for an agent-to-agent economy.</a:t>
+              <a:t>the most-regulated institutions are past experimentation — naming systems, publishing accuracy, and building payment rails.</a:t>
             </a:r>
           </a:p>
         </p:txBody>
@@ -11501,7 +11501,7 @@
               </a:lnSpc>
             </a:pPr>
             <a:r>
-              <a:rPr sz="1300" b="1">
+              <a:rPr sz="1250" b="1">
                 <a:solidFill>
                   <a:srgbClr val="0B1E3D"/>
                 </a:solidFill>
@@ -11510,13 +11510,13 @@
               <a:t>Bottom line:  </a:t>
             </a:r>
             <a:r>
-              <a:rPr sz="1300" b="0">
+              <a:rPr sz="1250" b="0">
                 <a:solidFill>
                   <a:srgbClr val="5A6B85"/>
                 </a:solidFill>
                 <a:latin typeface="Calibri"/>
               </a:rPr>
-              <a:t>the market has moved from “what is an agent?” to “who can run one under audit?” — and finance is where that test is being run first.</a:t>
+              <a:t>the market has moved from “what is an agent?” to “who can run one under audit?” — and finance is running that test first.</a:t>
             </a:r>
           </a:p>
         </p:txBody>
@@ -13107,7 +13107,7 @@
                 </a:solidFill>
                 <a:latin typeface="Calibri Light"/>
               </a:rPr>
-              <a:t>How big is the agentic AI market? Depends who's counting</a:t>
+              <a:t>Market sizing: it depends who's counting</a:t>
             </a:r>
           </a:p>
         </p:txBody>
@@ -15515,7 +15515,7 @@
                 </a:solidFill>
                 <a:latin typeface="Calibri Light"/>
               </a:rPr>
-              <a:t>Landscape: platforms consolidate, standards emerge, capital follows</a:t>
+              <a:t>Landscape: platforms, standards, and capital</a:t>
             </a:r>
           </a:p>
         </p:txBody>

</xml_diff>